<commit_message>
docs: test sayısını 51'e güncelle
Rapor ve sunum "32 API testi" diyordu; gerçek sayı 51 (api/src içinde
51 it/test bloğu). README.md, docs/TESLIMLER.md ve audit raporu zaten
51 diyordu, yani teslim paketi kendi içinde çelişiyordu.

Sayı generate_documents.py ve generate_slides.py içinde sabit yazılmış
olduğu için önce script'ler düzeltildi, sonra belgeler yeniden üretildi:

- Wayora-Proje-Raporu.docx: 3 yer (1.5 başarı kriterleri, 10. bölüm)
- Wayora-Proje-Yonetimi.docx: 1 yer (KPI tablosu)
- Wayora-Sunum.pptx: slayt 9 altbilgi, slayt 12 KPI, slayt 12 notu

User-Stories.docx test sayısı içermediği için dokunulmadı. Üretilen
dosyaların metni eski sürümlerle karşılaştırıldı; yalnızca bu satırlar
değişti.

Co-Authored-By: Claude Opus 5 <noreply@anthropic.com>
</commit_message>
<xml_diff>
--- a/docs/Wayora-Sunum.pptx
+++ b/docs/Wayora-Sunum.pptx
@@ -725,7 +725,7 @@
           <a:lstStyle/>
           <a:p>
             <a:r>
-              <a:t>Kalite deterministik guardrail’lere dayanıyor: 32 API, 4 web testi, lint, tip, build, audit, gitleaks, CodeQL ve Semgrep.</a:t>
+              <a:t>Kalite deterministik guardrail’lere dayanıyor: 51 API, 4 web testi, lint, tip, build, audit, gitleaks, CodeQL ve Semgrep.</a:t>
             </a:r>
           </a:p>
         </p:txBody>
@@ -8505,7 +8505,7 @@
                 </a:solidFill>
                 <a:latin typeface="Arial Black"/>
               </a:rPr>
-              <a:t>32</a:t>
+              <a:t>51</a:t>
             </a:r>
           </a:p>
         </p:txBody>
@@ -19481,7 +19481,7 @@
                 </a:solidFill>
                 <a:latin typeface="Consolas"/>
               </a:rPr>
-              <a:t>32 API + 4 web testi · 0 audit vulnerability · CI her PR’da</a:t>
+              <a:t>51 API + 4 web testi · 0 audit vulnerability · CI her PR’da</a:t>
             </a:r>
           </a:p>
         </p:txBody>

</xml_diff>

<commit_message>
docs: test sayısını 51'e güncelle (#19)
Rapor ve sunum "32 API testi" diyordu; gerçek sayı 51 (api/src içinde
51 it/test bloğu). README.md, docs/TESLIMLER.md ve audit raporu zaten
51 diyordu, yani teslim paketi kendi içinde çelişiyordu.

Sayı generate_documents.py ve generate_slides.py içinde sabit yazılmış
olduğu için önce script'ler düzeltildi, sonra belgeler yeniden üretildi:

- Wayora-Proje-Raporu.docx: 3 yer (1.5 başarı kriterleri, 10. bölüm)
- Wayora-Proje-Yonetimi.docx: 1 yer (KPI tablosu)
- Wayora-Sunum.pptx: slayt 9 altbilgi, slayt 12 KPI, slayt 12 notu

User-Stories.docx test sayısı içermediği için dokunulmadı. Üretilen
dosyaların metni eski sürümlerle karşılaştırıldı; yalnızca bu satırlar
değişti.

Co-authored-by: Claude Opus 5 <noreply@anthropic.com>
</commit_message>
<xml_diff>
--- a/docs/Wayora-Sunum.pptx
+++ b/docs/Wayora-Sunum.pptx
@@ -725,7 +725,7 @@
           <a:lstStyle/>
           <a:p>
             <a:r>
-              <a:t>Kalite deterministik guardrail’lere dayanıyor: 32 API, 4 web testi, lint, tip, build, audit, gitleaks, CodeQL ve Semgrep.</a:t>
+              <a:t>Kalite deterministik guardrail’lere dayanıyor: 51 API, 4 web testi, lint, tip, build, audit, gitleaks, CodeQL ve Semgrep.</a:t>
             </a:r>
           </a:p>
         </p:txBody>
@@ -8505,7 +8505,7 @@
                 </a:solidFill>
                 <a:latin typeface="Arial Black"/>
               </a:rPr>
-              <a:t>32</a:t>
+              <a:t>51</a:t>
             </a:r>
           </a:p>
         </p:txBody>
@@ -19481,7 +19481,7 @@
                 </a:solidFill>
                 <a:latin typeface="Consolas"/>
               </a:rPr>
-              <a:t>32 API + 4 web testi · 0 audit vulnerability · CI her PR’da</a:t>
+              <a:t>51 API + 4 web testi · 0 audit vulnerability · CI her PR’da</a:t>
             </a:r>
           </a:p>
         </p:txBody>

</xml_diff>

<commit_message>
docs: test sayısını 70 API + 6 web'e güncelle
Rapor ve sunum 51 API + 4 web diyordu; gece eklenen özelliklerle
(sosyal eşleştirme, 14 şehir/140 deneyim kataloğu, harita özellikleri)
gerçek sayı 70 API + 6 web'e çıktı.

Sayı generate_documents.py ve generate_slides.py içinde sabit
yazıldığı için önce script'ler düzeltildi, sonra belgeler bunlarla
yeniden üretildi:

- Wayora-Proje-Raporu.docx: 3 yer
- Wayora-Proje-Yonetimi.docx: 1 yer
- Wayora-Sunum.pptx: slayt 9 altbilgi, slayt 12 iki KPI sayısı, slayt
  12 konuşmacı notu

User-Stories.docx test sayısı içermediği için dokunulmadı. Üretilen
üç dosyanın metni HEAD'deki sürümlerle karşılaştırıldı; yalnızca bu
satırlar değişti.

Co-Authored-By: Claude Sonnet 5 <noreply@anthropic.com>
</commit_message>
<xml_diff>
--- a/docs/Wayora-Sunum.pptx
+++ b/docs/Wayora-Sunum.pptx
@@ -725,7 +725,7 @@
           <a:lstStyle/>
           <a:p>
             <a:r>
-              <a:t>Kalite deterministik guardrail’lere dayanıyor: 51 API, 4 web testi, lint, tip, build, audit, gitleaks, CodeQL ve Semgrep.</a:t>
+              <a:t>Kalite deterministik guardrail’lere dayanıyor: 70 API, 6 web testi, lint, tip, build, audit, gitleaks, CodeQL ve Semgrep.</a:t>
             </a:r>
           </a:p>
         </p:txBody>
@@ -8505,7 +8505,7 @@
                 </a:solidFill>
                 <a:latin typeface="Arial Black"/>
               </a:rPr>
-              <a:t>51</a:t>
+              <a:t>70</a:t>
             </a:r>
           </a:p>
         </p:txBody>
@@ -8583,7 +8583,7 @@
                 </a:solidFill>
                 <a:latin typeface="Arial Black"/>
               </a:rPr>
-              <a:t>4</a:t>
+              <a:t>6</a:t>
             </a:r>
           </a:p>
         </p:txBody>
@@ -19481,7 +19481,7 @@
                 </a:solidFill>
                 <a:latin typeface="Consolas"/>
               </a:rPr>
-              <a:t>51 API + 4 web testi · 0 audit vulnerability · CI her PR’da</a:t>
+              <a:t>70 API + 6 web testi · 0 audit vulnerability · CI her PR’da</a:t>
             </a:r>
           </a:p>
         </p:txBody>

</xml_diff>

<commit_message>
docs: test sayısını 70 API + 6 web'e güncelle (#45)
Rapor ve sunum 51 API + 4 web diyordu; gece eklenen özelliklerle
(sosyal eşleştirme, 14 şehir/140 deneyim kataloğu, harita özellikleri)
gerçek sayı 70 API + 6 web'e çıktı.

Sayı generate_documents.py ve generate_slides.py içinde sabit
yazıldığı için önce script'ler düzeltildi, sonra belgeler bunlarla
yeniden üretildi:

- Wayora-Proje-Raporu.docx: 3 yer
- Wayora-Proje-Yonetimi.docx: 1 yer
- Wayora-Sunum.pptx: slayt 9 altbilgi, slayt 12 iki KPI sayısı, slayt
  12 konuşmacı notu

User-Stories.docx test sayısı içermediği için dokunulmadı. Üretilen
üç dosyanın metni HEAD'deki sürümlerle karşılaştırıldı; yalnızca bu
satırlar değişti.

Co-authored-by: Claude Sonnet 5 <noreply@anthropic.com>
</commit_message>
<xml_diff>
--- a/docs/Wayora-Sunum.pptx
+++ b/docs/Wayora-Sunum.pptx
@@ -725,7 +725,7 @@
           <a:lstStyle/>
           <a:p>
             <a:r>
-              <a:t>Kalite deterministik guardrail’lere dayanıyor: 51 API, 4 web testi, lint, tip, build, audit, gitleaks, CodeQL ve Semgrep.</a:t>
+              <a:t>Kalite deterministik guardrail’lere dayanıyor: 70 API, 6 web testi, lint, tip, build, audit, gitleaks, CodeQL ve Semgrep.</a:t>
             </a:r>
           </a:p>
         </p:txBody>
@@ -8505,7 +8505,7 @@
                 </a:solidFill>
                 <a:latin typeface="Arial Black"/>
               </a:rPr>
-              <a:t>51</a:t>
+              <a:t>70</a:t>
             </a:r>
           </a:p>
         </p:txBody>
@@ -8583,7 +8583,7 @@
                 </a:solidFill>
                 <a:latin typeface="Arial Black"/>
               </a:rPr>
-              <a:t>4</a:t>
+              <a:t>6</a:t>
             </a:r>
           </a:p>
         </p:txBody>
@@ -19481,7 +19481,7 @@
                 </a:solidFill>
                 <a:latin typeface="Consolas"/>
               </a:rPr>
-              <a:t>51 API + 4 web testi · 0 audit vulnerability · CI her PR’da</a:t>
+              <a:t>70 API + 6 web testi · 0 audit vulnerability · CI her PR’da</a:t>
             </a:r>
           </a:p>
         </p:txBody>

</xml_diff>